<commit_message>
EP2: retriever semantico TF-IDF con metricas (IE4), replanificacion y priorizacion en el planificador (IE5), 38 pruebas y 11 escenarios de demo
- src/buscar_contexto.py: similitud coseno TF-IDF + normalizacion morfologica,
  embeddings densos opcionales y evaluar_recuperacion() (hit-rate@k, MRR).
- src/planificador.py: criticidad + priorizar() y replanificacion ante items
  invalidos (descarta y continua) con decision REPLANIFICACION.
- src/herramientas/escritura.py: parser tolerante (_parse_items_tolerante).
- tests: test_recuperacion.py + pruebas de replanificacion/priorizacion (29 -> 38).
- scripts/demo.py: escenarios de error/entrada ambigua y metricas del retriever (9 -> 11).
- Presentacion: PPT 10 -> 13 slides (metricas IE4, justificacion IE9, retos).
- README, informe (docx/md), guion y notebook Colab actualizados.
</commit_message>
<xml_diff>
--- a/presentacion/Presentacion_EP2_Ferrandes.pptx
+++ b/presentacion/Presentacion_EP2_Ferrandes.pptx
@@ -15,6 +15,9 @@
     <p:sldId id="263" r:id="rId14"/>
     <p:sldId id="264" r:id="rId15"/>
     <p:sldId id="265" r:id="rId16"/>
+    <p:sldId id="266" r:id="rId17"/>
+    <p:sldId id="267" r:id="rId18"/>
+    <p:sldId id="268" r:id="rId19"/>
   </p:sldIdLst>
   <p:sldSz cx="12191695" cy="6858000" type="screen4x3"/>
   <p:notesSz cx="6858000" cy="9144000"/>
@@ -3304,7 +3307,7 @@
               </a:defRPr>
             </a:pPr>
             <a:r>
-              <a:t>Cierre</a:t>
+              <a:t>Demo en vivo</a:t>
             </a:r>
           </a:p>
         </p:txBody>
@@ -3317,8 +3320,8 @@
         </p:nvSpPr>
         <p:spPr>
           <a:xfrm>
-            <a:off x="640080" y="1188720"/>
-            <a:ext cx="10972800" cy="4572000"/>
+            <a:off x="640080" y="1143000"/>
+            <a:ext cx="10972800" cy="4754880"/>
           </a:xfrm>
           <a:prstGeom prst="rect">
             <a:avLst/>
@@ -3335,16 +3338,601 @@
               <a:spcAft>
                 <a:spcPts val="800"/>
               </a:spcAft>
-              <a:defRPr sz="1800">
+              <a:defRPr sz="1600">
                 <a:solidFill>
                   <a:srgbClr val="606060"/>
                 </a:solidFill>
               </a:defRPr>
             </a:pPr>
             <a:r>
-              <a:t>Decisiones de diseño justificadas por alineación con el flujo (IE9).</a:t>
-            </a:r>
-          </a:p>
+              <a:t>1) Consulta de stock y precio (herramienta de consulta).</a:t>
+            </a:r>
+          </a:p>
+          <a:p>
+            <a:pPr>
+              <a:spcAft>
+                <a:spcPts val="800"/>
+              </a:spcAft>
+              <a:defRPr sz="1600">
+                <a:solidFill>
+                  <a:srgbClr val="606060"/>
+                </a:solidFill>
+              </a:defRPr>
+            </a:pPr>
+            <a:r>
+              <a:t>2) Pedido con faltante TOR-002: el agente emite OC y cotiza (adaptación).</a:t>
+            </a:r>
+          </a:p>
+          <a:p>
+            <a:pPr>
+              <a:spcAft>
+                <a:spcPts val="800"/>
+              </a:spcAft>
+              <a:defRPr sz="1600">
+                <a:solidFill>
+                  <a:srgbClr val="606060"/>
+                </a:solidFill>
+              </a:defRPr>
+            </a:pPr>
+            <a:r>
+              <a:t>3) Pedido que supera cupo: escalamiento a vendedor con ticket.</a:t>
+            </a:r>
+          </a:p>
+          <a:p>
+            <a:pPr>
+              <a:spcAft>
+                <a:spcPts val="800"/>
+              </a:spcAft>
+              <a:defRPr sz="1600">
+                <a:solidFill>
+                  <a:srgbClr val="606060"/>
+                </a:solidFill>
+              </a:defRPr>
+            </a:pPr>
+            <a:r>
+              <a:t>4) Ítems inválidos: replanifica y continúa con los válidos.</a:t>
+            </a:r>
+          </a:p>
+          <a:p>
+            <a:pPr>
+              <a:spcAft>
+                <a:spcPts val="800"/>
+              </a:spcAft>
+              <a:defRPr sz="1600">
+                <a:solidFill>
+                  <a:srgbClr val="606060"/>
+                </a:solidFill>
+              </a:defRPr>
+            </a:pPr>
+            <a:r>
+              <a:t>Comando: python scripts/demo.py   |   python tests/ejecutar_tests.py</a:t>
+            </a:r>
+          </a:p>
+          <a:p>
+            <a:pPr>
+              <a:spcAft>
+                <a:spcPts val="800"/>
+              </a:spcAft>
+              <a:defRPr sz="1600">
+                <a:solidFill>
+                  <a:srgbClr val="606060"/>
+                </a:solidFill>
+              </a:defRPr>
+            </a:pPr>
+            <a:r>
+              <a:t>Respaldo si falla en vivo: evidencia/ + notebook de Colab ya ejecutado.</a:t>
+            </a:r>
+          </a:p>
+        </p:txBody>
+      </p:sp>
+    </p:spTree>
+  </p:cSld>
+  <p:clrMapOvr>
+    <a:masterClrMapping/>
+  </p:clrMapOvr>
+</p:sld>
+</file>
+
+<file path=ppt/slides/slide11.xml><?xml version="1.0" encoding="utf-8"?>
+<p:sld xmlns:a="http://schemas.openxmlformats.org/drawingml/2006/main" xmlns:p="http://schemas.openxmlformats.org/presentationml/2006/main" xmlns:r="http://schemas.openxmlformats.org/officeDocument/2006/relationships">
+  <p:cSld>
+    <p:spTree>
+      <p:nvGrpSpPr>
+        <p:cNvPr id="1" name=""/>
+        <p:cNvGrpSpPr/>
+        <p:nvPr/>
+      </p:nvGrpSpPr>
+      <p:grpSpPr/>
+      <p:sp>
+        <p:nvSpPr>
+          <p:cNvPr id="3" name="Rectangle 2"/>
+          <p:cNvSpPr/>
+          <p:nvPr/>
+        </p:nvSpPr>
+        <p:spPr>
+          <a:xfrm>
+            <a:off x="0" y="0"/>
+            <a:ext cx="12191695" cy="914400"/>
+          </a:xfrm>
+          <a:prstGeom prst="rect">
+            <a:avLst/>
+          </a:prstGeom>
+          <a:solidFill>
+            <a:srgbClr val="1F4E79"/>
+          </a:solidFill>
+          <a:ln>
+            <a:noFill/>
+          </a:ln>
+          <a:effectLst/>
+        </p:spPr>
+        <p:style>
+          <a:lnRef idx="1">
+            <a:schemeClr val="accent1"/>
+          </a:lnRef>
+          <a:fillRef idx="3">
+            <a:schemeClr val="accent1"/>
+          </a:fillRef>
+          <a:effectRef idx="2">
+            <a:schemeClr val="accent1"/>
+          </a:effectRef>
+          <a:fontRef idx="minor">
+            <a:schemeClr val="lt1"/>
+          </a:fontRef>
+        </p:style>
+        <p:txBody>
+          <a:bodyPr rtlCol="0" anchor="ctr"/>
+          <a:lstStyle/>
+          <a:p>
+            <a:pPr algn="ctr"/>
+          </a:p>
+        </p:txBody>
+      </p:sp>
+      <p:sp>
+        <p:nvSpPr>
+          <p:cNvPr id="2" name="TextBox 1"/>
+          <p:cNvSpPr txBox="1"/>
+          <p:nvPr/>
+        </p:nvSpPr>
+        <p:spPr>
+          <a:xfrm>
+            <a:off x="0" y="0"/>
+            <a:ext cx="12191695" cy="914400"/>
+          </a:xfrm>
+          <a:prstGeom prst="rect">
+            <a:avLst/>
+          </a:prstGeom>
+          <a:noFill/>
+        </p:spPr>
+        <p:txBody>
+          <a:bodyPr wrap="none" lIns="457200" tIns="137160">
+            <a:spAutoFit/>
+          </a:bodyPr>
+          <a:lstStyle/>
+          <a:p>
+            <a:pPr>
+              <a:defRPr sz="3000" b="1">
+                <a:solidFill>
+                  <a:srgbClr val="FFFFFF"/>
+                </a:solidFill>
+              </a:defRPr>
+            </a:pPr>
+            <a:r>
+              <a:t>Evidencia y resultados</a:t>
+            </a:r>
+          </a:p>
+        </p:txBody>
+      </p:sp>
+      <p:sp>
+        <p:nvSpPr>
+          <p:cNvPr id="4" name="TextBox 3"/>
+          <p:cNvSpPr txBox="1"/>
+          <p:nvPr/>
+        </p:nvSpPr>
+        <p:spPr>
+          <a:xfrm>
+            <a:off x="640080" y="1188720"/>
+            <a:ext cx="10972800" cy="4572000"/>
+          </a:xfrm>
+          <a:prstGeom prst="rect">
+            <a:avLst/>
+          </a:prstGeom>
+          <a:noFill/>
+        </p:spPr>
+        <p:txBody>
+          <a:bodyPr wrap="square">
+            <a:spAutoFit/>
+          </a:bodyPr>
+          <a:lstStyle/>
+          <a:p>
+            <a:pPr>
+              <a:spcAft>
+                <a:spcPts val="800"/>
+              </a:spcAft>
+              <a:defRPr sz="1700">
+                <a:solidFill>
+                  <a:srgbClr val="606060"/>
+                </a:solidFill>
+              </a:defRPr>
+            </a:pPr>
+            <a:r>
+              <a:t>38 pruebas unitarias validadas (tests/ejecutar_tests.py) — todas 'ok'.</a:t>
+            </a:r>
+          </a:p>
+          <a:p>
+            <a:pPr>
+              <a:spcAft>
+                <a:spcPts val="800"/>
+              </a:spcAft>
+              <a:defRPr sz="1700">
+                <a:solidFill>
+                  <a:srgbClr val="606060"/>
+                </a:solidFill>
+              </a:defRPr>
+            </a:pPr>
+            <a:r>
+              <a:t>11 escenarios de negocio en evidencia/evidencia_pruebas.txt.</a:t>
+            </a:r>
+          </a:p>
+          <a:p>
+            <a:pPr>
+              <a:spcAft>
+                <a:spcPts val="800"/>
+              </a:spcAft>
+              <a:defRPr sz="1700">
+                <a:solidFill>
+                  <a:srgbClr val="606060"/>
+                </a:solidFill>
+              </a:defRPr>
+            </a:pPr>
+            <a:r>
+              <a:t>Retriever: hit-rate@3 = 100 % · MRR = 1,00 (8 consultas etiquetadas).</a:t>
+            </a:r>
+          </a:p>
+          <a:p>
+            <a:pPr>
+              <a:spcAft>
+                <a:spcPts val="800"/>
+              </a:spcAft>
+              <a:defRPr sz="1700">
+                <a:solidFill>
+                  <a:srgbClr val="606060"/>
+                </a:solidFill>
+              </a:defRPr>
+            </a:pPr>
+            <a:r>
+              <a:t>Flujos: PEDIDO_CONFIRMADO, EN_APROBACION, DERIVADO, REPLANIFICADO.</a:t>
+            </a:r>
+          </a:p>
+          <a:p>
+            <a:pPr>
+              <a:spcAft>
+                <a:spcPts val="800"/>
+              </a:spcAft>
+              <a:defRPr sz="1700">
+                <a:solidFill>
+                  <a:srgbClr val="606060"/>
+                </a:solidFill>
+              </a:defRPr>
+            </a:pPr>
+            <a:r>
+              <a:t>README + diagramas de orquestación + informe técnico (≤5 páginas).</a:t>
+            </a:r>
+          </a:p>
+        </p:txBody>
+      </p:sp>
+    </p:spTree>
+  </p:cSld>
+  <p:clrMapOvr>
+    <a:masterClrMapping/>
+  </p:clrMapOvr>
+</p:sld>
+</file>
+
+<file path=ppt/slides/slide12.xml><?xml version="1.0" encoding="utf-8"?>
+<p:sld xmlns:a="http://schemas.openxmlformats.org/drawingml/2006/main" xmlns:p="http://schemas.openxmlformats.org/presentationml/2006/main" xmlns:r="http://schemas.openxmlformats.org/officeDocument/2006/relationships">
+  <p:cSld>
+    <p:spTree>
+      <p:nvGrpSpPr>
+        <p:cNvPr id="1" name=""/>
+        <p:cNvGrpSpPr/>
+        <p:nvPr/>
+      </p:nvGrpSpPr>
+      <p:grpSpPr/>
+      <p:sp>
+        <p:nvSpPr>
+          <p:cNvPr id="3" name="Rectangle 2"/>
+          <p:cNvSpPr/>
+          <p:nvPr/>
+        </p:nvSpPr>
+        <p:spPr>
+          <a:xfrm>
+            <a:off x="0" y="0"/>
+            <a:ext cx="12191695" cy="914400"/>
+          </a:xfrm>
+          <a:prstGeom prst="rect">
+            <a:avLst/>
+          </a:prstGeom>
+          <a:solidFill>
+            <a:srgbClr val="1F4E79"/>
+          </a:solidFill>
+          <a:ln>
+            <a:noFill/>
+          </a:ln>
+          <a:effectLst/>
+        </p:spPr>
+        <p:style>
+          <a:lnRef idx="1">
+            <a:schemeClr val="accent1"/>
+          </a:lnRef>
+          <a:fillRef idx="3">
+            <a:schemeClr val="accent1"/>
+          </a:fillRef>
+          <a:effectRef idx="2">
+            <a:schemeClr val="accent1"/>
+          </a:effectRef>
+          <a:fontRef idx="minor">
+            <a:schemeClr val="lt1"/>
+          </a:fontRef>
+        </p:style>
+        <p:txBody>
+          <a:bodyPr rtlCol="0" anchor="ctr"/>
+          <a:lstStyle/>
+          <a:p>
+            <a:pPr algn="ctr"/>
+          </a:p>
+        </p:txBody>
+      </p:sp>
+      <p:sp>
+        <p:nvSpPr>
+          <p:cNvPr id="2" name="TextBox 1"/>
+          <p:cNvSpPr txBox="1"/>
+          <p:nvPr/>
+        </p:nvSpPr>
+        <p:spPr>
+          <a:xfrm>
+            <a:off x="0" y="0"/>
+            <a:ext cx="12191695" cy="914400"/>
+          </a:xfrm>
+          <a:prstGeom prst="rect">
+            <a:avLst/>
+          </a:prstGeom>
+          <a:noFill/>
+        </p:spPr>
+        <p:txBody>
+          <a:bodyPr wrap="none" lIns="457200" tIns="137160">
+            <a:spAutoFit/>
+          </a:bodyPr>
+          <a:lstStyle/>
+          <a:p>
+            <a:pPr>
+              <a:defRPr sz="3000" b="1">
+                <a:solidFill>
+                  <a:srgbClr val="FFFFFF"/>
+                </a:solidFill>
+              </a:defRPr>
+            </a:pPr>
+            <a:r>
+              <a:t>Retos, límites y próximos pasos</a:t>
+            </a:r>
+          </a:p>
+        </p:txBody>
+      </p:sp>
+      <p:sp>
+        <p:nvSpPr>
+          <p:cNvPr id="4" name="TextBox 3"/>
+          <p:cNvSpPr txBox="1"/>
+          <p:nvPr/>
+        </p:nvSpPr>
+        <p:spPr>
+          <a:xfrm>
+            <a:off x="640080" y="1188720"/>
+            <a:ext cx="10972800" cy="4572000"/>
+          </a:xfrm>
+          <a:prstGeom prst="rect">
+            <a:avLst/>
+          </a:prstGeom>
+          <a:noFill/>
+        </p:spPr>
+        <p:txBody>
+          <a:bodyPr wrap="square">
+            <a:spAutoFit/>
+          </a:bodyPr>
+          <a:lstStyle/>
+          <a:p>
+            <a:pPr>
+              <a:spcAft>
+                <a:spcPts val="800"/>
+              </a:spcAft>
+              <a:defRPr sz="1700">
+                <a:solidFill>
+                  <a:srgbClr val="606060"/>
+                </a:solidFill>
+              </a:defRPr>
+            </a:pPr>
+            <a:r>
+              <a:t>Límite: el grafo LangChain se validó con un LLM simulado (sin API key en la sala).</a:t>
+            </a:r>
+          </a:p>
+          <a:p>
+            <a:pPr>
+              <a:spcAft>
+                <a:spcPts val="800"/>
+              </a:spcAft>
+              <a:defRPr sz="1700">
+                <a:solidFill>
+                  <a:srgbClr val="606060"/>
+                </a:solidFill>
+              </a:defRPr>
+            </a:pPr>
+            <a:r>
+              <a:t>Límite: el retriever es TF-IDF; los embeddings densos son opcionales.</a:t>
+            </a:r>
+          </a:p>
+          <a:p>
+            <a:pPr>
+              <a:spcAft>
+                <a:spcPts val="800"/>
+              </a:spcAft>
+              <a:defRPr sz="1700">
+                <a:solidFill>
+                  <a:srgbClr val="606060"/>
+                </a:solidFill>
+              </a:defRPr>
+            </a:pPr>
+            <a:r>
+              <a:t>Próximo paso: embeddings reales + vector store (Chroma/FAISS) y medición de calidad.</a:t>
+            </a:r>
+          </a:p>
+          <a:p>
+            <a:pPr>
+              <a:spcAft>
+                <a:spcPts val="800"/>
+              </a:spcAft>
+              <a:defRPr sz="1700">
+                <a:solidFill>
+                  <a:srgbClr val="606060"/>
+                </a:solidFill>
+              </a:defRPr>
+            </a:pPr>
+            <a:r>
+              <a:t>Próximo paso: memoria LangChain explícita en el grafo (checkpointer) y traza con LLM real.</a:t>
+            </a:r>
+          </a:p>
+          <a:p>
+            <a:pPr>
+              <a:spcAft>
+                <a:spcPts val="800"/>
+              </a:spcAft>
+              <a:defRPr sz="1700">
+                <a:solidFill>
+                  <a:srgbClr val="606060"/>
+                </a:solidFill>
+              </a:defRPr>
+            </a:pPr>
+            <a:r>
+              <a:t>Próximo paso: despliegue con PostgreSQL y pruebas con datos de producción.</a:t>
+            </a:r>
+          </a:p>
+        </p:txBody>
+      </p:sp>
+    </p:spTree>
+  </p:cSld>
+  <p:clrMapOvr>
+    <a:masterClrMapping/>
+  </p:clrMapOvr>
+</p:sld>
+</file>
+
+<file path=ppt/slides/slide13.xml><?xml version="1.0" encoding="utf-8"?>
+<p:sld xmlns:a="http://schemas.openxmlformats.org/drawingml/2006/main" xmlns:p="http://schemas.openxmlformats.org/presentationml/2006/main" xmlns:r="http://schemas.openxmlformats.org/officeDocument/2006/relationships">
+  <p:cSld>
+    <p:spTree>
+      <p:nvGrpSpPr>
+        <p:cNvPr id="1" name=""/>
+        <p:cNvGrpSpPr/>
+        <p:nvPr/>
+      </p:nvGrpSpPr>
+      <p:grpSpPr/>
+      <p:sp>
+        <p:nvSpPr>
+          <p:cNvPr id="3" name="Rectangle 2"/>
+          <p:cNvSpPr/>
+          <p:nvPr/>
+        </p:nvSpPr>
+        <p:spPr>
+          <a:xfrm>
+            <a:off x="0" y="0"/>
+            <a:ext cx="12191695" cy="914400"/>
+          </a:xfrm>
+          <a:prstGeom prst="rect">
+            <a:avLst/>
+          </a:prstGeom>
+          <a:solidFill>
+            <a:srgbClr val="1F4E79"/>
+          </a:solidFill>
+          <a:ln>
+            <a:noFill/>
+          </a:ln>
+          <a:effectLst/>
+        </p:spPr>
+        <p:style>
+          <a:lnRef idx="1">
+            <a:schemeClr val="accent1"/>
+          </a:lnRef>
+          <a:fillRef idx="3">
+            <a:schemeClr val="accent1"/>
+          </a:fillRef>
+          <a:effectRef idx="2">
+            <a:schemeClr val="accent1"/>
+          </a:effectRef>
+          <a:fontRef idx="minor">
+            <a:schemeClr val="lt1"/>
+          </a:fontRef>
+        </p:style>
+        <p:txBody>
+          <a:bodyPr rtlCol="0" anchor="ctr"/>
+          <a:lstStyle/>
+          <a:p>
+            <a:pPr algn="ctr"/>
+          </a:p>
+        </p:txBody>
+      </p:sp>
+      <p:sp>
+        <p:nvSpPr>
+          <p:cNvPr id="2" name="TextBox 1"/>
+          <p:cNvSpPr txBox="1"/>
+          <p:nvPr/>
+        </p:nvSpPr>
+        <p:spPr>
+          <a:xfrm>
+            <a:off x="0" y="0"/>
+            <a:ext cx="12191695" cy="914400"/>
+          </a:xfrm>
+          <a:prstGeom prst="rect">
+            <a:avLst/>
+          </a:prstGeom>
+          <a:noFill/>
+        </p:spPr>
+        <p:txBody>
+          <a:bodyPr wrap="none" lIns="457200" tIns="137160">
+            <a:spAutoFit/>
+          </a:bodyPr>
+          <a:lstStyle/>
+          <a:p>
+            <a:pPr>
+              <a:defRPr sz="3000" b="1">
+                <a:solidFill>
+                  <a:srgbClr val="FFFFFF"/>
+                </a:solidFill>
+              </a:defRPr>
+            </a:pPr>
+            <a:r>
+              <a:t>Cierre</a:t>
+            </a:r>
+          </a:p>
+        </p:txBody>
+      </p:sp>
+      <p:sp>
+        <p:nvSpPr>
+          <p:cNvPr id="4" name="TextBox 3"/>
+          <p:cNvSpPr txBox="1"/>
+          <p:nvPr/>
+        </p:nvSpPr>
+        <p:spPr>
+          <a:xfrm>
+            <a:off x="640080" y="1188720"/>
+            <a:ext cx="10972800" cy="4572000"/>
+          </a:xfrm>
+          <a:prstGeom prst="rect">
+            <a:avLst/>
+          </a:prstGeom>
+          <a:noFill/>
+        </p:spPr>
+        <p:txBody>
+          <a:bodyPr wrap="square">
+            <a:spAutoFit/>
+          </a:bodyPr>
+          <a:lstStyle/>
           <a:p>
             <a:pPr>
               <a:spcAft>
@@ -3357,7 +3945,7 @@
               </a:defRPr>
             </a:pPr>
             <a:r>
-              <a:t>Autonomía demostrada: decisión adaptativa ante stock, crédito y normativa.</a:t>
+              <a:t>Decisiones de diseño justificadas por alineación con el flujo (IE9).</a:t>
             </a:r>
           </a:p>
           <a:p>
@@ -3372,7 +3960,7 @@
               </a:defRPr>
             </a:pPr>
             <a:r>
-              <a:t>Repositorio: código + documentación + evidencia reproducible.</a:t>
+              <a:t>Autonomía demostrada: decisión adaptativa ante stock, crédito, normativa e ítems inválidos.</a:t>
             </a:r>
           </a:p>
           <a:p>
@@ -3387,7 +3975,22 @@
               </a:defRPr>
             </a:pPr>
             <a:r>
-              <a:t>Siguiente paso: embeddings reales (Chroma/FAISS) y despliegue en la organización.</a:t>
+              <a:t>Repositorio: código + documentación + evidencia reproducible (38 pruebas, hit-rate@3 100 %).</a:t>
+            </a:r>
+          </a:p>
+          <a:p>
+            <a:pPr>
+              <a:spcAft>
+                <a:spcPts val="800"/>
+              </a:spcAft>
+              <a:defRPr sz="1800">
+                <a:solidFill>
+                  <a:srgbClr val="606060"/>
+                </a:solidFill>
+              </a:defRPr>
+            </a:pPr>
+            <a:r>
+              <a:t>Siguiente paso: embeddings reales (Chroma/FAISS), memoria LangChain y despliegue.</a:t>
             </a:r>
           </a:p>
           <a:p>
@@ -4331,7 +4934,7 @@
               </a:defRPr>
             </a:pPr>
             <a:r>
-              <a:t>Recuperación semántica (RAG): retriever sobre catálogo, políticas y FAQs (mismo enfoque EP1).</a:t>
+              <a:t>Recuperación de contexto: retriever semántico TF-IDF + embeddings densos opcionales (IE4).</a:t>
             </a:r>
           </a:p>
           <a:p>
@@ -4443,45 +5046,21 @@
               </a:defRPr>
             </a:pPr>
             <a:r>
-              <a:t>Planificación y decisiones adaptativas (IL2.3)</a:t>
-            </a:r>
-          </a:p>
-        </p:txBody>
-      </p:sp>
-      <p:pic>
-        <p:nvPicPr>
-          <p:cNvPr id="4" name="Picture 3" descr="diagrama_flujo_pedido.png"/>
-          <p:cNvPicPr>
-            <a:picLocks noChangeAspect="1"/>
-          </p:cNvPicPr>
-          <p:nvPr/>
-        </p:nvPicPr>
-        <p:blipFill>
-          <a:blip r:embed="rId2"/>
-          <a:stretch>
-            <a:fillRect/>
-          </a:stretch>
-        </p:blipFill>
-        <p:spPr>
-          <a:xfrm>
-            <a:off x="457200" y="1051560"/>
-            <a:ext cx="2627724" cy="5486400"/>
-          </a:xfrm>
-          <a:prstGeom prst="rect">
-            <a:avLst/>
-          </a:prstGeom>
-        </p:spPr>
-      </p:pic>
-      <p:sp>
-        <p:nvSpPr>
-          <p:cNvPr id="5" name="TextBox 4"/>
+              <a:t>Recuperación semántica: mejora y métricas (IE4)</a:t>
+            </a:r>
+          </a:p>
+        </p:txBody>
+      </p:sp>
+      <p:sp>
+        <p:nvSpPr>
+          <p:cNvPr id="4" name="TextBox 3"/>
           <p:cNvSpPr txBox="1"/>
           <p:nvPr/>
         </p:nvSpPr>
         <p:spPr>
           <a:xfrm>
-            <a:off x="4206240" y="1371600"/>
-            <a:ext cx="7498079" cy="4572000"/>
+            <a:off x="640080" y="1188720"/>
+            <a:ext cx="10972800" cy="4572000"/>
           </a:xfrm>
           <a:prstGeom prst="rect">
             <a:avLst/>
@@ -4498,14 +5077,14 @@
               <a:spcAft>
                 <a:spcPts val="800"/>
               </a:spcAft>
-              <a:defRPr sz="1600">
-                <a:solidFill>
-                  <a:srgbClr val="E67E22"/>
-                </a:solidFill>
-              </a:defRPr>
-            </a:pPr>
-            <a:r>
-              <a:t>Stock bajo → OC automática + entrega programada.</a:t>
+              <a:defRPr sz="1700">
+                <a:solidFill>
+                  <a:srgbClr val="606060"/>
+                </a:solidFill>
+              </a:defRPr>
+            </a:pPr>
+            <a:r>
+              <a:t>Similitud coseno sobre vectores TF-IDF (pondera términos discriminantes y normaliza).</a:t>
             </a:r>
           </a:p>
           <a:p>
@@ -4513,14 +5092,14 @@
               <a:spcAft>
                 <a:spcPts val="800"/>
               </a:spcAft>
-              <a:defRPr sz="1600">
-                <a:solidFill>
-                  <a:srgbClr val="E67E22"/>
-                </a:solidFill>
-              </a:defRPr>
-            </a:pPr>
-            <a:r>
-              <a:t>Monto &gt; cupo/umbral → EN_APROBACION + ticket.</a:t>
+              <a:defRPr sz="1700">
+                <a:solidFill>
+                  <a:srgbClr val="606060"/>
+                </a:solidFill>
+              </a:defRPr>
+            </a:pPr>
+            <a:r>
+              <a:t>Normalización morfológica ligera: “ubicados” empareja con “ubicación”.</a:t>
             </a:r>
           </a:p>
           <a:p>
@@ -4528,14 +5107,14 @@
               <a:spcAft>
                 <a:spcPts val="800"/>
               </a:spcAft>
-              <a:defRPr sz="1600">
-                <a:solidFill>
-                  <a:srgbClr val="E67E22"/>
-                </a:solidFill>
-              </a:defRPr>
-            </a:pPr>
-            <a:r>
-              <a:t>Cliente nuevo → pago contra entrega.</a:t>
+              <a:defRPr sz="1700">
+                <a:solidFill>
+                  <a:srgbClr val="606060"/>
+                </a:solidFill>
+              </a:defRPr>
+            </a:pPr>
+            <a:r>
+              <a:t>Embeddings densos opcionales (sentence-transformers) sin cambiar la interfaz.</a:t>
             </a:r>
           </a:p>
           <a:p>
@@ -4543,14 +5122,29 @@
               <a:spcAft>
                 <a:spcPts val="800"/>
               </a:spcAft>
-              <a:defRPr sz="1600">
-                <a:solidFill>
-                  <a:srgbClr val="E67E22"/>
-                </a:solidFill>
-              </a:defRPr>
-            </a:pPr>
-            <a:r>
-              <a:t>Normativa EPP → deriva a especialista (guardrail).</a:t>
+              <a:defRPr sz="1700">
+                <a:solidFill>
+                  <a:srgbClr val="606060"/>
+                </a:solidFill>
+              </a:defRPr>
+            </a:pPr>
+            <a:r>
+              <a:t>Medición objetiva: evaluar_recuperacion() → hit-rate@k y MRR.</a:t>
+            </a:r>
+          </a:p>
+          <a:p>
+            <a:pPr>
+              <a:spcAft>
+                <a:spcPts val="800"/>
+              </a:spcAft>
+              <a:defRPr sz="1700">
+                <a:solidFill>
+                  <a:srgbClr val="606060"/>
+                </a:solidFill>
+              </a:defRPr>
+            </a:pPr>
+            <a:r>
+              <a:t>Resultado: hit-rate@3 = 100 % · MRR = 1,00 (8 consultas etiquetadas).</a:t>
             </a:r>
           </a:p>
         </p:txBody>
@@ -4647,21 +5241,45 @@
               </a:defRPr>
             </a:pPr>
             <a:r>
-              <a:t>Demo en vivo</a:t>
-            </a:r>
-          </a:p>
-        </p:txBody>
-      </p:sp>
-      <p:sp>
-        <p:nvSpPr>
-          <p:cNvPr id="4" name="TextBox 3"/>
+              <a:t>Planificación y decisiones adaptativas (IL2.3)</a:t>
+            </a:r>
+          </a:p>
+        </p:txBody>
+      </p:sp>
+      <p:pic>
+        <p:nvPicPr>
+          <p:cNvPr id="4" name="Picture 3" descr="diagrama_flujo_pedido.png"/>
+          <p:cNvPicPr>
+            <a:picLocks noChangeAspect="1"/>
+          </p:cNvPicPr>
+          <p:nvPr/>
+        </p:nvPicPr>
+        <p:blipFill>
+          <a:blip r:embed="rId2"/>
+          <a:stretch>
+            <a:fillRect/>
+          </a:stretch>
+        </p:blipFill>
+        <p:spPr>
+          <a:xfrm>
+            <a:off x="457200" y="1051560"/>
+            <a:ext cx="2627724" cy="5486400"/>
+          </a:xfrm>
+          <a:prstGeom prst="rect">
+            <a:avLst/>
+          </a:prstGeom>
+        </p:spPr>
+      </p:pic>
+      <p:sp>
+        <p:nvSpPr>
+          <p:cNvPr id="5" name="TextBox 4"/>
           <p:cNvSpPr txBox="1"/>
           <p:nvPr/>
         </p:nvSpPr>
         <p:spPr>
           <a:xfrm>
-            <a:off x="640080" y="1188720"/>
-            <a:ext cx="10972800" cy="4572000"/>
+            <a:off x="4206240" y="1234440"/>
+            <a:ext cx="7498079" cy="5029200"/>
           </a:xfrm>
           <a:prstGeom prst="rect">
             <a:avLst/>
@@ -4678,14 +5296,14 @@
               <a:spcAft>
                 <a:spcPts val="800"/>
               </a:spcAft>
-              <a:defRPr sz="1800">
-                <a:solidFill>
-                  <a:srgbClr val="606060"/>
-                </a:solidFill>
-              </a:defRPr>
-            </a:pPr>
-            <a:r>
-              <a:t>1) Consulta de stock y precio (herramienta de consulta).</a:t>
+              <a:defRPr sz="1500">
+                <a:solidFill>
+                  <a:srgbClr val="E67E22"/>
+                </a:solidFill>
+              </a:defRPr>
+            </a:pPr>
+            <a:r>
+              <a:t>Plan priorizado por criticidad (6 etapas).</a:t>
             </a:r>
           </a:p>
           <a:p>
@@ -4693,14 +5311,14 @@
               <a:spcAft>
                 <a:spcPts val="800"/>
               </a:spcAft>
-              <a:defRPr sz="1800">
-                <a:solidFill>
-                  <a:srgbClr val="606060"/>
-                </a:solidFill>
-              </a:defRPr>
-            </a:pPr>
-            <a:r>
-              <a:t>2) Pedido con faltante TOR-002: el agente emite OC y cotiza (adaptación).</a:t>
+              <a:defRPr sz="1500">
+                <a:solidFill>
+                  <a:srgbClr val="E67E22"/>
+                </a:solidFill>
+              </a:defRPr>
+            </a:pPr>
+            <a:r>
+              <a:t>Stock bajo → OC automática + entrega programada.</a:t>
             </a:r>
           </a:p>
           <a:p>
@@ -4708,14 +5326,14 @@
               <a:spcAft>
                 <a:spcPts val="800"/>
               </a:spcAft>
-              <a:defRPr sz="1800">
-                <a:solidFill>
-                  <a:srgbClr val="606060"/>
-                </a:solidFill>
-              </a:defRPr>
-            </a:pPr>
-            <a:r>
-              <a:t>3) Pedido que supera cupo: escalamiento a vendedor con ticket.</a:t>
+              <a:defRPr sz="1500">
+                <a:solidFill>
+                  <a:srgbClr val="E67E22"/>
+                </a:solidFill>
+              </a:defRPr>
+            </a:pPr>
+            <a:r>
+              <a:t>Monto &gt; cupo/umbral → EN_APROBACION + ticket.</a:t>
             </a:r>
           </a:p>
           <a:p>
@@ -4723,14 +5341,14 @@
               <a:spcAft>
                 <a:spcPts val="800"/>
               </a:spcAft>
-              <a:defRPr sz="1800">
-                <a:solidFill>
-                  <a:srgbClr val="606060"/>
-                </a:solidFill>
-              </a:defRPr>
-            </a:pPr>
-            <a:r>
-              <a:t>4) Memoria: estado del pedido PAT-000001 retomado en otra consulta.</a:t>
+              <a:defRPr sz="1500">
+                <a:solidFill>
+                  <a:srgbClr val="E67E22"/>
+                </a:solidFill>
+              </a:defRPr>
+            </a:pPr>
+            <a:r>
+              <a:t>Cliente nuevo → pago contra entrega.</a:t>
             </a:r>
           </a:p>
           <a:p>
@@ -4738,14 +5356,29 @@
               <a:spcAft>
                 <a:spcPts val="800"/>
               </a:spcAft>
-              <a:defRPr sz="1800">
-                <a:solidFill>
-                  <a:srgbClr val="606060"/>
-                </a:solidFill>
-              </a:defRPr>
-            </a:pPr>
-            <a:r>
-              <a:t>Comando: python scripts/demo.py (sin API, sin costo).</a:t>
+              <a:defRPr sz="1500">
+                <a:solidFill>
+                  <a:srgbClr val="E67E22"/>
+                </a:solidFill>
+              </a:defRPr>
+            </a:pPr>
+            <a:r>
+              <a:t>Normativa EPP → deriva a especialista (guardrail).</a:t>
+            </a:r>
+          </a:p>
+          <a:p>
+            <a:pPr>
+              <a:spcAft>
+                <a:spcPts val="800"/>
+              </a:spcAft>
+              <a:defRPr sz="1500">
+                <a:solidFill>
+                  <a:srgbClr val="E67E22"/>
+                </a:solidFill>
+              </a:defRPr>
+            </a:pPr>
+            <a:r>
+              <a:t>Ítems inválidos → REPLANIFICA y continúa.</a:t>
             </a:r>
           </a:p>
         </p:txBody>
@@ -4842,7 +5475,7 @@
               </a:defRPr>
             </a:pPr>
             <a:r>
-              <a:t>Evidencia y resultados</a:t>
+              <a:t>Justificación de la orquestación (IE8, IE9)</a:t>
             </a:r>
           </a:p>
         </p:txBody>
@@ -4873,14 +5506,14 @@
               <a:spcAft>
                 <a:spcPts val="800"/>
               </a:spcAft>
-              <a:defRPr sz="1700">
+              <a:defRPr sz="1600">
                 <a:solidFill>
                   <a:srgbClr val="606060"/>
                 </a:solidFill>
               </a:defRPr>
             </a:pPr>
             <a:r>
-              <a:t>29 pruebas unitarias validadas (tests/ejecutar_tests.py) — todas 'ok'.</a:t>
+              <a:t>LangChain create_agent: grafo oficial, documentado, cambia de modelo (Claude o simulado).</a:t>
             </a:r>
           </a:p>
           <a:p>
@@ -4888,14 +5521,14 @@
               <a:spcAft>
                 <a:spcPts val="800"/>
               </a:spcAft>
-              <a:defRPr sz="1700">
+              <a:defRPr sz="1600">
                 <a:solidFill>
                   <a:srgbClr val="606060"/>
                 </a:solidFill>
               </a:defRPr>
             </a:pPr>
             <a:r>
-              <a:t>9 escenarios de negocio en evidencia/evidencia_pruebas.txt.</a:t>
+              <a:t>Herramientas puras por familia (consulta/escritura/razonamiento): separación de efectos y testeo.</a:t>
             </a:r>
           </a:p>
           <a:p>
@@ -4903,14 +5536,14 @@
               <a:spcAft>
                 <a:spcPts val="800"/>
               </a:spcAft>
-              <a:defRPr sz="1700">
+              <a:defRPr sz="1600">
                 <a:solidFill>
                   <a:srgbClr val="606060"/>
                 </a:solidFill>
               </a:defRPr>
             </a:pPr>
             <a:r>
-              <a:t>Smoke test del grafo LangChain offline: evidencia/evidencia_langchain.txt.</a:t>
+              <a:t>SQLite como memoria de largo plazo: persistencia sin servidor, migrable a PostgreSQL.</a:t>
             </a:r>
           </a:p>
           <a:p>
@@ -4918,14 +5551,14 @@
               <a:spcAft>
                 <a:spcPts val="800"/>
               </a:spcAft>
-              <a:defRPr sz="1700">
+              <a:defRPr sz="1600">
                 <a:solidFill>
                   <a:srgbClr val="606060"/>
                 </a:solidFill>
               </a:defRPr>
             </a:pPr>
             <a:r>
-              <a:t>Flujos: PEDIDO_CONFIRMADO, EN_APROBACION, DERIVADO (guardrail).</a:t>
+              <a:t>Retriever TF-IDF: precisión medible hoy y ruta directa a embeddings/vector store.</a:t>
             </a:r>
           </a:p>
           <a:p>
@@ -4933,14 +5566,14 @@
               <a:spcAft>
                 <a:spcPts val="800"/>
               </a:spcAft>
-              <a:defRPr sz="1700">
+              <a:defRPr sz="1600">
                 <a:solidFill>
                   <a:srgbClr val="606060"/>
                 </a:solidFill>
               </a:defRPr>
             </a:pPr>
             <a:r>
-              <a:t>README + diagramas de orquestación + informe técnico (5 páginas).</a:t>
+              <a:t>Planificador priorizado: cada paso ligado a un requisito del flujo (stock, crédito, SLA).</a:t>
             </a:r>
           </a:p>
         </p:txBody>

</xml_diff>